<commit_message>
revisions figure tweaking; multiple regressions for TA-ED
very small aesthetic changes
</commit_message>
<xml_diff>
--- a/figures/conceptual/conceptual_threepanel.pptx
+++ b/figures/conceptual/conceptual_threepanel.pptx
@@ -5,7 +5,7 @@
     <p:sldMasterId id="2147483660" r:id="rId1"/>
   </p:sldMasterIdLst>
   <p:notesMasterIdLst>
-    <p:notesMasterId r:id="rId7"/>
+    <p:notesMasterId r:id="rId9"/>
   </p:notesMasterIdLst>
   <p:sldIdLst>
     <p:sldId id="256" r:id="rId2"/>
@@ -13,6 +13,8 @@
     <p:sldId id="258" r:id="rId4"/>
     <p:sldId id="260" r:id="rId5"/>
     <p:sldId id="261" r:id="rId6"/>
+    <p:sldId id="262" r:id="rId7"/>
+    <p:sldId id="263" r:id="rId8"/>
   </p:sldIdLst>
   <p:sldSz cx="12192000" cy="11898313"/>
   <p:notesSz cx="6858000" cy="9144000"/>
@@ -201,7 +203,7 @@
           <a:p>
             <a:fld id="{3CCF9D45-BAE5-2444-B4A9-18EFA8B28771}" type="datetimeFigureOut">
               <a:rPr lang="en-US" smtClean="0"/>
-              <a:t>10/2/25</a:t>
+              <a:t>2/3/26</a:t>
             </a:fld>
             <a:endParaRPr lang="en-US"/>
           </a:p>
@@ -875,7 +877,7 @@
           <a:p>
             <a:fld id="{F6F5C077-26A2-1C4D-A264-F91E44095E52}" type="datetimeFigureOut">
               <a:rPr lang="en-US" smtClean="0"/>
-              <a:t>10/2/25</a:t>
+              <a:t>2/3/26</a:t>
             </a:fld>
             <a:endParaRPr lang="en-US"/>
           </a:p>
@@ -1045,7 +1047,7 @@
           <a:p>
             <a:fld id="{F6F5C077-26A2-1C4D-A264-F91E44095E52}" type="datetimeFigureOut">
               <a:rPr lang="en-US" smtClean="0"/>
-              <a:t>10/2/25</a:t>
+              <a:t>2/3/26</a:t>
             </a:fld>
             <a:endParaRPr lang="en-US"/>
           </a:p>
@@ -1225,7 +1227,7 @@
           <a:p>
             <a:fld id="{F6F5C077-26A2-1C4D-A264-F91E44095E52}" type="datetimeFigureOut">
               <a:rPr lang="en-US" smtClean="0"/>
-              <a:t>10/2/25</a:t>
+              <a:t>2/3/26</a:t>
             </a:fld>
             <a:endParaRPr lang="en-US"/>
           </a:p>
@@ -1395,7 +1397,7 @@
           <a:p>
             <a:fld id="{F6F5C077-26A2-1C4D-A264-F91E44095E52}" type="datetimeFigureOut">
               <a:rPr lang="en-US" smtClean="0"/>
-              <a:t>10/2/25</a:t>
+              <a:t>2/3/26</a:t>
             </a:fld>
             <a:endParaRPr lang="en-US"/>
           </a:p>
@@ -1641,7 +1643,7 @@
           <a:p>
             <a:fld id="{F6F5C077-26A2-1C4D-A264-F91E44095E52}" type="datetimeFigureOut">
               <a:rPr lang="en-US" smtClean="0"/>
-              <a:t>10/2/25</a:t>
+              <a:t>2/3/26</a:t>
             </a:fld>
             <a:endParaRPr lang="en-US"/>
           </a:p>
@@ -1873,7 +1875,7 @@
           <a:p>
             <a:fld id="{F6F5C077-26A2-1C4D-A264-F91E44095E52}" type="datetimeFigureOut">
               <a:rPr lang="en-US" smtClean="0"/>
-              <a:t>10/2/25</a:t>
+              <a:t>2/3/26</a:t>
             </a:fld>
             <a:endParaRPr lang="en-US"/>
           </a:p>
@@ -2240,7 +2242,7 @@
           <a:p>
             <a:fld id="{F6F5C077-26A2-1C4D-A264-F91E44095E52}" type="datetimeFigureOut">
               <a:rPr lang="en-US" smtClean="0"/>
-              <a:t>10/2/25</a:t>
+              <a:t>2/3/26</a:t>
             </a:fld>
             <a:endParaRPr lang="en-US"/>
           </a:p>
@@ -2358,7 +2360,7 @@
           <a:p>
             <a:fld id="{F6F5C077-26A2-1C4D-A264-F91E44095E52}" type="datetimeFigureOut">
               <a:rPr lang="en-US" smtClean="0"/>
-              <a:t>10/2/25</a:t>
+              <a:t>2/3/26</a:t>
             </a:fld>
             <a:endParaRPr lang="en-US"/>
           </a:p>
@@ -2453,7 +2455,7 @@
           <a:p>
             <a:fld id="{F6F5C077-26A2-1C4D-A264-F91E44095E52}" type="datetimeFigureOut">
               <a:rPr lang="en-US" smtClean="0"/>
-              <a:t>10/2/25</a:t>
+              <a:t>2/3/26</a:t>
             </a:fld>
             <a:endParaRPr lang="en-US"/>
           </a:p>
@@ -2730,7 +2732,7 @@
           <a:p>
             <a:fld id="{F6F5C077-26A2-1C4D-A264-F91E44095E52}" type="datetimeFigureOut">
               <a:rPr lang="en-US" smtClean="0"/>
-              <a:t>10/2/25</a:t>
+              <a:t>2/3/26</a:t>
             </a:fld>
             <a:endParaRPr lang="en-US"/>
           </a:p>
@@ -2987,7 +2989,7 @@
           <a:p>
             <a:fld id="{F6F5C077-26A2-1C4D-A264-F91E44095E52}" type="datetimeFigureOut">
               <a:rPr lang="en-US" smtClean="0"/>
-              <a:t>10/2/25</a:t>
+              <a:t>2/3/26</a:t>
             </a:fld>
             <a:endParaRPr lang="en-US"/>
           </a:p>
@@ -3200,7 +3202,7 @@
           <a:p>
             <a:fld id="{F6F5C077-26A2-1C4D-A264-F91E44095E52}" type="datetimeFigureOut">
               <a:rPr lang="en-US" smtClean="0"/>
-              <a:t>10/2/25</a:t>
+              <a:t>2/3/26</a:t>
             </a:fld>
             <a:endParaRPr lang="en-US"/>
           </a:p>
@@ -5157,6 +5159,638 @@
     <p:extLst>
       <p:ext uri="{BB962C8B-B14F-4D97-AF65-F5344CB8AC3E}">
         <p14:creationId xmlns:p14="http://schemas.microsoft.com/office/powerpoint/2010/main" val="2773077735"/>
+      </p:ext>
+    </p:extLst>
+  </p:cSld>
+  <p:clrMapOvr>
+    <a:masterClrMapping/>
+  </p:clrMapOvr>
+</p:sld>
+</file>
+
+<file path=ppt/slides/slide6.xml><?xml version="1.0" encoding="utf-8"?>
+<p:sld xmlns:a="http://schemas.openxmlformats.org/drawingml/2006/main" xmlns:r="http://schemas.openxmlformats.org/officeDocument/2006/relationships" xmlns:p="http://schemas.openxmlformats.org/presentationml/2006/main">
+  <p:cSld>
+    <p:spTree>
+      <p:nvGrpSpPr>
+        <p:cNvPr id="1" name=""/>
+        <p:cNvGrpSpPr/>
+        <p:nvPr/>
+      </p:nvGrpSpPr>
+      <p:grpSpPr>
+        <a:xfrm>
+          <a:off x="0" y="0"/>
+          <a:ext cx="0" cy="0"/>
+          <a:chOff x="0" y="0"/>
+          <a:chExt cx="0" cy="0"/>
+        </a:xfrm>
+      </p:grpSpPr>
+      <p:pic>
+        <p:nvPicPr>
+          <p:cNvPr id="4" name="Picture 3" descr="A diagram of a diagram&#10;&#10;AI-generated content may be incorrect.">
+            <a:extLst>
+              <a:ext uri="{FF2B5EF4-FFF2-40B4-BE49-F238E27FC236}">
+                <a16:creationId xmlns:a16="http://schemas.microsoft.com/office/drawing/2014/main" id="{1BF4EF58-6227-5BAE-A282-8B14C470FC98}"/>
+              </a:ext>
+            </a:extLst>
+          </p:cNvPr>
+          <p:cNvPicPr>
+            <a:picLocks noChangeAspect="1"/>
+          </p:cNvPicPr>
+          <p:nvPr/>
+        </p:nvPicPr>
+        <p:blipFill>
+          <a:blip r:embed="rId2"/>
+          <a:stretch>
+            <a:fillRect/>
+          </a:stretch>
+        </p:blipFill>
+        <p:spPr>
+          <a:xfrm>
+            <a:off x="3877048" y="0"/>
+            <a:ext cx="4437903" cy="3676249"/>
+          </a:xfrm>
+          <a:prstGeom prst="rect">
+            <a:avLst/>
+          </a:prstGeom>
+        </p:spPr>
+      </p:pic>
+      <p:pic>
+        <p:nvPicPr>
+          <p:cNvPr id="5" name="Picture 4" descr="A diagram of a heat exchanger&#10;&#10;AI-generated content may be incorrect.">
+            <a:extLst>
+              <a:ext uri="{FF2B5EF4-FFF2-40B4-BE49-F238E27FC236}">
+                <a16:creationId xmlns:a16="http://schemas.microsoft.com/office/drawing/2014/main" id="{99933912-6339-E712-CF9E-8F8EF6AB14B7}"/>
+              </a:ext>
+            </a:extLst>
+          </p:cNvPr>
+          <p:cNvPicPr>
+            <a:picLocks noChangeAspect="1"/>
+          </p:cNvPicPr>
+          <p:nvPr/>
+        </p:nvPicPr>
+        <p:blipFill>
+          <a:blip r:embed="rId3"/>
+          <a:srcRect t="8208" b="80712"/>
+          <a:stretch/>
+        </p:blipFill>
+        <p:spPr>
+          <a:xfrm>
+            <a:off x="1813110" y="7737633"/>
+            <a:ext cx="9639442" cy="490414"/>
+          </a:xfrm>
+          <a:prstGeom prst="rect">
+            <a:avLst/>
+          </a:prstGeom>
+        </p:spPr>
+      </p:pic>
+      <p:pic>
+        <p:nvPicPr>
+          <p:cNvPr id="6" name="Picture 5" descr="A diagram of a thermal asymmetrical system&#10;&#10;AI-generated content may be incorrect.">
+            <a:extLst>
+              <a:ext uri="{FF2B5EF4-FFF2-40B4-BE49-F238E27FC236}">
+                <a16:creationId xmlns:a16="http://schemas.microsoft.com/office/drawing/2014/main" id="{33E6AF83-3040-95C2-23A4-80DD923C9AAA}"/>
+              </a:ext>
+            </a:extLst>
+          </p:cNvPr>
+          <p:cNvPicPr>
+            <a:picLocks noChangeAspect="1"/>
+          </p:cNvPicPr>
+          <p:nvPr/>
+        </p:nvPicPr>
+        <p:blipFill>
+          <a:blip r:embed="rId4"/>
+          <a:srcRect t="7070" b="82932"/>
+          <a:stretch/>
+        </p:blipFill>
+        <p:spPr>
+          <a:xfrm>
+            <a:off x="1619250" y="3662804"/>
+            <a:ext cx="9460753" cy="470642"/>
+          </a:xfrm>
+          <a:prstGeom prst="rect">
+            <a:avLst/>
+          </a:prstGeom>
+        </p:spPr>
+      </p:pic>
+      <p:sp>
+        <p:nvSpPr>
+          <p:cNvPr id="7" name="TextBox 6">
+            <a:extLst>
+              <a:ext uri="{FF2B5EF4-FFF2-40B4-BE49-F238E27FC236}">
+                <a16:creationId xmlns:a16="http://schemas.microsoft.com/office/drawing/2014/main" id="{88F081AA-079E-0854-433D-A991B253962E}"/>
+              </a:ext>
+            </a:extLst>
+          </p:cNvPr>
+          <p:cNvSpPr txBox="1"/>
+          <p:nvPr/>
+        </p:nvSpPr>
+        <p:spPr>
+          <a:xfrm>
+            <a:off x="656747" y="317789"/>
+            <a:ext cx="731520" cy="461665"/>
+          </a:xfrm>
+          <a:prstGeom prst="rect">
+            <a:avLst/>
+          </a:prstGeom>
+          <a:noFill/>
+        </p:spPr>
+        <p:txBody>
+          <a:bodyPr wrap="square" rtlCol="0">
+            <a:spAutoFit/>
+          </a:bodyPr>
+          <a:lstStyle/>
+          <a:p>
+            <a:r>
+              <a:rPr lang="en-US" sz="2400" b="1" dirty="0"/>
+              <a:t>A</a:t>
+            </a:r>
+            <a:endParaRPr lang="en-US" b="1" dirty="0"/>
+          </a:p>
+        </p:txBody>
+      </p:sp>
+      <p:sp>
+        <p:nvSpPr>
+          <p:cNvPr id="8" name="TextBox 7">
+            <a:extLst>
+              <a:ext uri="{FF2B5EF4-FFF2-40B4-BE49-F238E27FC236}">
+                <a16:creationId xmlns:a16="http://schemas.microsoft.com/office/drawing/2014/main" id="{F358CED9-ED29-1C3A-5F4D-E4BB00AD042A}"/>
+              </a:ext>
+            </a:extLst>
+          </p:cNvPr>
+          <p:cNvSpPr txBox="1"/>
+          <p:nvPr/>
+        </p:nvSpPr>
+        <p:spPr>
+          <a:xfrm>
+            <a:off x="656747" y="3682996"/>
+            <a:ext cx="731520" cy="461665"/>
+          </a:xfrm>
+          <a:prstGeom prst="rect">
+            <a:avLst/>
+          </a:prstGeom>
+          <a:noFill/>
+        </p:spPr>
+        <p:txBody>
+          <a:bodyPr wrap="square" rtlCol="0">
+            <a:spAutoFit/>
+          </a:bodyPr>
+          <a:lstStyle/>
+          <a:p>
+            <a:r>
+              <a:rPr lang="en-US" sz="2400" b="1" dirty="0"/>
+              <a:t>B</a:t>
+            </a:r>
+            <a:endParaRPr lang="en-US" b="1" dirty="0"/>
+          </a:p>
+        </p:txBody>
+      </p:sp>
+      <p:sp>
+        <p:nvSpPr>
+          <p:cNvPr id="9" name="TextBox 8">
+            <a:extLst>
+              <a:ext uri="{FF2B5EF4-FFF2-40B4-BE49-F238E27FC236}">
+                <a16:creationId xmlns:a16="http://schemas.microsoft.com/office/drawing/2014/main" id="{EA43C1E5-1BD2-77C6-CBAB-A79C701D3436}"/>
+              </a:ext>
+            </a:extLst>
+          </p:cNvPr>
+          <p:cNvSpPr txBox="1"/>
+          <p:nvPr/>
+        </p:nvSpPr>
+        <p:spPr>
+          <a:xfrm>
+            <a:off x="656747" y="7737633"/>
+            <a:ext cx="731520" cy="461665"/>
+          </a:xfrm>
+          <a:prstGeom prst="rect">
+            <a:avLst/>
+          </a:prstGeom>
+          <a:noFill/>
+        </p:spPr>
+        <p:txBody>
+          <a:bodyPr wrap="square" rtlCol="0">
+            <a:spAutoFit/>
+          </a:bodyPr>
+          <a:lstStyle/>
+          <a:p>
+            <a:r>
+              <a:rPr lang="en-US" sz="2400" b="1" dirty="0"/>
+              <a:t>C</a:t>
+            </a:r>
+            <a:endParaRPr lang="en-US" b="1" dirty="0"/>
+          </a:p>
+        </p:txBody>
+      </p:sp>
+      <p:pic>
+        <p:nvPicPr>
+          <p:cNvPr id="11" name="Picture 10" descr="A diagram of a graph&#10;&#10;AI-generated content may be incorrect.">
+            <a:extLst>
+              <a:ext uri="{FF2B5EF4-FFF2-40B4-BE49-F238E27FC236}">
+                <a16:creationId xmlns:a16="http://schemas.microsoft.com/office/drawing/2014/main" id="{0747A782-3AF9-4A6D-A10C-36386C6B1F15}"/>
+              </a:ext>
+            </a:extLst>
+          </p:cNvPr>
+          <p:cNvPicPr>
+            <a:picLocks noChangeAspect="1"/>
+          </p:cNvPicPr>
+          <p:nvPr/>
+        </p:nvPicPr>
+        <p:blipFill>
+          <a:blip r:embed="rId5"/>
+          <a:srcRect t="23333" b="5757"/>
+          <a:stretch/>
+        </p:blipFill>
+        <p:spPr>
+          <a:xfrm>
+            <a:off x="822679" y="4173202"/>
+            <a:ext cx="11104277" cy="3470114"/>
+          </a:xfrm>
+          <a:prstGeom prst="rect">
+            <a:avLst/>
+          </a:prstGeom>
+        </p:spPr>
+      </p:pic>
+      <p:pic>
+        <p:nvPicPr>
+          <p:cNvPr id="13" name="Picture 12" descr="A diagram of a graph&#10;&#10;AI-generated content may be incorrect.">
+            <a:extLst>
+              <a:ext uri="{FF2B5EF4-FFF2-40B4-BE49-F238E27FC236}">
+                <a16:creationId xmlns:a16="http://schemas.microsoft.com/office/drawing/2014/main" id="{56C9063E-FEAE-E5F9-C8AD-C0403BD40193}"/>
+              </a:ext>
+            </a:extLst>
+          </p:cNvPr>
+          <p:cNvPicPr>
+            <a:picLocks noChangeAspect="1"/>
+          </p:cNvPicPr>
+          <p:nvPr/>
+        </p:nvPicPr>
+        <p:blipFill>
+          <a:blip r:embed="rId6"/>
+          <a:srcRect t="24483"/>
+          <a:stretch/>
+        </p:blipFill>
+        <p:spPr>
+          <a:xfrm>
+            <a:off x="888940" y="8322365"/>
+            <a:ext cx="10563612" cy="3258159"/>
+          </a:xfrm>
+          <a:prstGeom prst="rect">
+            <a:avLst/>
+          </a:prstGeom>
+        </p:spPr>
+      </p:pic>
+    </p:spTree>
+    <p:extLst>
+      <p:ext uri="{BB962C8B-B14F-4D97-AF65-F5344CB8AC3E}">
+        <p14:creationId xmlns:p14="http://schemas.microsoft.com/office/powerpoint/2010/main" val="42355712"/>
+      </p:ext>
+    </p:extLst>
+  </p:cSld>
+  <p:clrMapOvr>
+    <a:masterClrMapping/>
+  </p:clrMapOvr>
+</p:sld>
+</file>
+
+<file path=ppt/slides/slide7.xml><?xml version="1.0" encoding="utf-8"?>
+<p:sld xmlns:a="http://schemas.openxmlformats.org/drawingml/2006/main" xmlns:r="http://schemas.openxmlformats.org/officeDocument/2006/relationships" xmlns:p="http://schemas.openxmlformats.org/presentationml/2006/main">
+  <p:cSld>
+    <p:spTree>
+      <p:nvGrpSpPr>
+        <p:cNvPr id="1" name="">
+          <a:extLst>
+            <a:ext uri="{FF2B5EF4-FFF2-40B4-BE49-F238E27FC236}">
+              <a16:creationId xmlns:a16="http://schemas.microsoft.com/office/drawing/2014/main" id="{B88D09BF-7F43-3B14-B819-A7EE33302D18}"/>
+            </a:ext>
+          </a:extLst>
+        </p:cNvPr>
+        <p:cNvGrpSpPr/>
+        <p:nvPr/>
+      </p:nvGrpSpPr>
+      <p:grpSpPr>
+        <a:xfrm>
+          <a:off x="0" y="0"/>
+          <a:ext cx="0" cy="0"/>
+          <a:chOff x="0" y="0"/>
+          <a:chExt cx="0" cy="0"/>
+        </a:xfrm>
+      </p:grpSpPr>
+      <p:pic>
+        <p:nvPicPr>
+          <p:cNvPr id="4" name="Picture 3" descr="A diagram of a diagram&#10;&#10;AI-generated content may be incorrect.">
+            <a:extLst>
+              <a:ext uri="{FF2B5EF4-FFF2-40B4-BE49-F238E27FC236}">
+                <a16:creationId xmlns:a16="http://schemas.microsoft.com/office/drawing/2014/main" id="{4655A3AF-BA64-E62C-CDC3-54480DC3D97E}"/>
+              </a:ext>
+            </a:extLst>
+          </p:cNvPr>
+          <p:cNvPicPr>
+            <a:picLocks noChangeAspect="1"/>
+          </p:cNvPicPr>
+          <p:nvPr/>
+        </p:nvPicPr>
+        <p:blipFill>
+          <a:blip r:embed="rId2"/>
+          <a:stretch>
+            <a:fillRect/>
+          </a:stretch>
+        </p:blipFill>
+        <p:spPr>
+          <a:xfrm>
+            <a:off x="3877048" y="0"/>
+            <a:ext cx="4437903" cy="3676249"/>
+          </a:xfrm>
+          <a:prstGeom prst="rect">
+            <a:avLst/>
+          </a:prstGeom>
+        </p:spPr>
+      </p:pic>
+      <p:pic>
+        <p:nvPicPr>
+          <p:cNvPr id="5" name="Picture 4" descr="A diagram of a heat exchanger&#10;&#10;AI-generated content may be incorrect.">
+            <a:extLst>
+              <a:ext uri="{FF2B5EF4-FFF2-40B4-BE49-F238E27FC236}">
+                <a16:creationId xmlns:a16="http://schemas.microsoft.com/office/drawing/2014/main" id="{08B47095-C776-9E8B-0AC2-1942A4F91D12}"/>
+              </a:ext>
+            </a:extLst>
+          </p:cNvPr>
+          <p:cNvPicPr>
+            <a:picLocks noChangeAspect="1"/>
+          </p:cNvPicPr>
+          <p:nvPr/>
+        </p:nvPicPr>
+        <p:blipFill>
+          <a:blip r:embed="rId3"/>
+          <a:srcRect t="8208" b="80712"/>
+          <a:stretch/>
+        </p:blipFill>
+        <p:spPr>
+          <a:xfrm>
+            <a:off x="1462912" y="7716765"/>
+            <a:ext cx="10934360" cy="593913"/>
+          </a:xfrm>
+          <a:prstGeom prst="rect">
+            <a:avLst/>
+          </a:prstGeom>
+        </p:spPr>
+      </p:pic>
+      <p:pic>
+        <p:nvPicPr>
+          <p:cNvPr id="6" name="Picture 5" descr="A diagram of a thermal asymmetrical system&#10;&#10;AI-generated content may be incorrect.">
+            <a:extLst>
+              <a:ext uri="{FF2B5EF4-FFF2-40B4-BE49-F238E27FC236}">
+                <a16:creationId xmlns:a16="http://schemas.microsoft.com/office/drawing/2014/main" id="{4F0F3337-95A6-204A-B349-C4ABC4F2B68C}"/>
+              </a:ext>
+            </a:extLst>
+          </p:cNvPr>
+          <p:cNvPicPr>
+            <a:picLocks noChangeAspect="1"/>
+          </p:cNvPicPr>
+          <p:nvPr/>
+        </p:nvPicPr>
+        <p:blipFill>
+          <a:blip r:embed="rId4"/>
+          <a:srcRect t="7070" b="82932"/>
+          <a:stretch/>
+        </p:blipFill>
+        <p:spPr>
+          <a:xfrm>
+            <a:off x="1231365" y="3583717"/>
+            <a:ext cx="10845144" cy="539511"/>
+          </a:xfrm>
+          <a:prstGeom prst="rect">
+            <a:avLst/>
+          </a:prstGeom>
+        </p:spPr>
+      </p:pic>
+      <p:sp>
+        <p:nvSpPr>
+          <p:cNvPr id="7" name="TextBox 6">
+            <a:extLst>
+              <a:ext uri="{FF2B5EF4-FFF2-40B4-BE49-F238E27FC236}">
+                <a16:creationId xmlns:a16="http://schemas.microsoft.com/office/drawing/2014/main" id="{01425DA9-B784-FC38-7C1B-9BFB7B0F1F69}"/>
+              </a:ext>
+            </a:extLst>
+          </p:cNvPr>
+          <p:cNvSpPr txBox="1"/>
+          <p:nvPr/>
+        </p:nvSpPr>
+        <p:spPr>
+          <a:xfrm>
+            <a:off x="656747" y="317789"/>
+            <a:ext cx="731520" cy="461665"/>
+          </a:xfrm>
+          <a:prstGeom prst="rect">
+            <a:avLst/>
+          </a:prstGeom>
+          <a:noFill/>
+        </p:spPr>
+        <p:txBody>
+          <a:bodyPr wrap="square" rtlCol="0">
+            <a:spAutoFit/>
+          </a:bodyPr>
+          <a:lstStyle/>
+          <a:p>
+            <a:r>
+              <a:rPr lang="en-US" sz="2400" b="1" dirty="0"/>
+              <a:t>A</a:t>
+            </a:r>
+            <a:endParaRPr lang="en-US" b="1" dirty="0"/>
+          </a:p>
+        </p:txBody>
+      </p:sp>
+      <p:sp>
+        <p:nvSpPr>
+          <p:cNvPr id="8" name="TextBox 7">
+            <a:extLst>
+              <a:ext uri="{FF2B5EF4-FFF2-40B4-BE49-F238E27FC236}">
+                <a16:creationId xmlns:a16="http://schemas.microsoft.com/office/drawing/2014/main" id="{3D17EDDC-BDB4-8C16-BA2C-DD21DA00098E}"/>
+              </a:ext>
+            </a:extLst>
+          </p:cNvPr>
+          <p:cNvSpPr txBox="1"/>
+          <p:nvPr/>
+        </p:nvSpPr>
+        <p:spPr>
+          <a:xfrm>
+            <a:off x="656747" y="3682996"/>
+            <a:ext cx="731520" cy="461665"/>
+          </a:xfrm>
+          <a:prstGeom prst="rect">
+            <a:avLst/>
+          </a:prstGeom>
+          <a:noFill/>
+        </p:spPr>
+        <p:txBody>
+          <a:bodyPr wrap="square" rtlCol="0">
+            <a:spAutoFit/>
+          </a:bodyPr>
+          <a:lstStyle/>
+          <a:p>
+            <a:r>
+              <a:rPr lang="en-US" sz="2400" b="1" dirty="0"/>
+              <a:t>B</a:t>
+            </a:r>
+            <a:endParaRPr lang="en-US" b="1" dirty="0"/>
+          </a:p>
+        </p:txBody>
+      </p:sp>
+      <p:sp>
+        <p:nvSpPr>
+          <p:cNvPr id="9" name="TextBox 8">
+            <a:extLst>
+              <a:ext uri="{FF2B5EF4-FFF2-40B4-BE49-F238E27FC236}">
+                <a16:creationId xmlns:a16="http://schemas.microsoft.com/office/drawing/2014/main" id="{5A4019BD-0158-C890-D515-9822A572B4F8}"/>
+              </a:ext>
+            </a:extLst>
+          </p:cNvPr>
+          <p:cNvSpPr txBox="1"/>
+          <p:nvPr/>
+        </p:nvSpPr>
+        <p:spPr>
+          <a:xfrm>
+            <a:off x="656747" y="7737633"/>
+            <a:ext cx="731520" cy="461665"/>
+          </a:xfrm>
+          <a:prstGeom prst="rect">
+            <a:avLst/>
+          </a:prstGeom>
+          <a:noFill/>
+        </p:spPr>
+        <p:txBody>
+          <a:bodyPr wrap="square" rtlCol="0">
+            <a:spAutoFit/>
+          </a:bodyPr>
+          <a:lstStyle/>
+          <a:p>
+            <a:r>
+              <a:rPr lang="en-US" sz="2400" b="1" dirty="0"/>
+              <a:t>C</a:t>
+            </a:r>
+            <a:endParaRPr lang="en-US" b="1" dirty="0"/>
+          </a:p>
+        </p:txBody>
+      </p:sp>
+      <p:pic>
+        <p:nvPicPr>
+          <p:cNvPr id="3" name="Picture 2">
+            <a:extLst>
+              <a:ext uri="{FF2B5EF4-FFF2-40B4-BE49-F238E27FC236}">
+                <a16:creationId xmlns:a16="http://schemas.microsoft.com/office/drawing/2014/main" id="{11592518-7527-E0B2-C38B-1CB5E251254E}"/>
+              </a:ext>
+            </a:extLst>
+          </p:cNvPr>
+          <p:cNvPicPr>
+            <a:picLocks noChangeAspect="1"/>
+          </p:cNvPicPr>
+          <p:nvPr/>
+        </p:nvPicPr>
+        <p:blipFill>
+          <a:blip r:embed="rId5"/>
+          <a:srcRect t="23250" b="22056"/>
+          <a:stretch/>
+        </p:blipFill>
+        <p:spPr>
+          <a:xfrm>
+            <a:off x="165338" y="4128127"/>
+            <a:ext cx="11768881" cy="3620721"/>
+          </a:xfrm>
+          <a:prstGeom prst="rect">
+            <a:avLst/>
+          </a:prstGeom>
+        </p:spPr>
+      </p:pic>
+      <p:pic>
+        <p:nvPicPr>
+          <p:cNvPr id="15" name="Picture 14">
+            <a:extLst>
+              <a:ext uri="{FF2B5EF4-FFF2-40B4-BE49-F238E27FC236}">
+                <a16:creationId xmlns:a16="http://schemas.microsoft.com/office/drawing/2014/main" id="{2B45FDA6-F4F9-BC4C-D0E9-0C0771DF6211}"/>
+              </a:ext>
+            </a:extLst>
+          </p:cNvPr>
+          <p:cNvPicPr>
+            <a:picLocks noChangeAspect="1"/>
+          </p:cNvPicPr>
+          <p:nvPr/>
+        </p:nvPicPr>
+        <p:blipFill>
+          <a:blip r:embed="rId6"/>
+          <a:srcRect l="38002" t="27276" r="30764" b="21747"/>
+          <a:stretch/>
+        </p:blipFill>
+        <p:spPr>
+          <a:xfrm>
+            <a:off x="4598758" y="8300682"/>
+            <a:ext cx="3918857" cy="3597631"/>
+          </a:xfrm>
+          <a:prstGeom prst="rect">
+            <a:avLst/>
+          </a:prstGeom>
+        </p:spPr>
+      </p:pic>
+      <p:pic>
+        <p:nvPicPr>
+          <p:cNvPr id="16" name="Picture 15">
+            <a:extLst>
+              <a:ext uri="{FF2B5EF4-FFF2-40B4-BE49-F238E27FC236}">
+                <a16:creationId xmlns:a16="http://schemas.microsoft.com/office/drawing/2014/main" id="{060B348E-B863-706E-3444-B7057ECF0EE2}"/>
+              </a:ext>
+            </a:extLst>
+          </p:cNvPr>
+          <p:cNvPicPr>
+            <a:picLocks noChangeAspect="1"/>
+          </p:cNvPicPr>
+          <p:nvPr/>
+        </p:nvPicPr>
+        <p:blipFill>
+          <a:blip r:embed="rId6"/>
+          <a:srcRect l="70333" t="27011" r="738" b="22012"/>
+          <a:stretch/>
+        </p:blipFill>
+        <p:spPr>
+          <a:xfrm>
+            <a:off x="8314951" y="8193980"/>
+            <a:ext cx="3761558" cy="3728258"/>
+          </a:xfrm>
+          <a:prstGeom prst="rect">
+            <a:avLst/>
+          </a:prstGeom>
+        </p:spPr>
+      </p:pic>
+      <p:pic>
+        <p:nvPicPr>
+          <p:cNvPr id="17" name="Picture 16">
+            <a:extLst>
+              <a:ext uri="{FF2B5EF4-FFF2-40B4-BE49-F238E27FC236}">
+                <a16:creationId xmlns:a16="http://schemas.microsoft.com/office/drawing/2014/main" id="{1E4781EB-EC31-461F-D2AE-FA0BA25DCC6E}"/>
+              </a:ext>
+            </a:extLst>
+          </p:cNvPr>
+          <p:cNvPicPr>
+            <a:picLocks noChangeAspect="1"/>
+          </p:cNvPicPr>
+          <p:nvPr/>
+        </p:nvPicPr>
+        <p:blipFill>
+          <a:blip r:embed="rId6"/>
+          <a:srcRect l="299" t="24112" r="62890" b="24911"/>
+          <a:stretch/>
+        </p:blipFill>
+        <p:spPr>
+          <a:xfrm>
+            <a:off x="202660" y="8209095"/>
+            <a:ext cx="4340115" cy="3380721"/>
+          </a:xfrm>
+          <a:prstGeom prst="rect">
+            <a:avLst/>
+          </a:prstGeom>
+        </p:spPr>
+      </p:pic>
+    </p:spTree>
+    <p:extLst>
+      <p:ext uri="{BB962C8B-B14F-4D97-AF65-F5344CB8AC3E}">
+        <p14:creationId xmlns:p14="http://schemas.microsoft.com/office/powerpoint/2010/main" val="4254312096"/>
       </p:ext>
     </p:extLst>
   </p:cSld>

</xml_diff>